<commit_message>
feat: QEMU VNC 지원 답변과 Community 선제 알림 고도화
</commit_message>
<xml_diff>
--- a/output/presentation/techflow-versioned-safe-answer.pptx
+++ b/output/presentation/techflow-versioned-safe-answer.pptx
@@ -2,18 +2,18 @@
 <file path=ppt/presentation.xml><?xml version="1.0" encoding="utf-8"?>
 <p:presentation xmlns:p="http://schemas.openxmlformats.org/presentationml/2006/main">
   <p:sldMasterIdLst>
-    <p:sldMasterId xmlns:r="http://schemas.openxmlformats.org/officeDocument/2006/relationships" id="2147483648" r:id="R455c98813a4748b4"/>
+    <p:sldMasterId xmlns:r="http://schemas.openxmlformats.org/officeDocument/2006/relationships" id="2147483648" r:id="Rb5f39d3034214ed3"/>
   </p:sldMasterIdLst>
   <p:notesMasterIdLst>
-    <p:notesMasterId xmlns:r="http://schemas.openxmlformats.org/officeDocument/2006/relationships" r:id="Re8dd4817db174851"/>
+    <p:notesMasterId xmlns:r="http://schemas.openxmlformats.org/officeDocument/2006/relationships" r:id="R1367cdebb07b4405"/>
   </p:notesMasterIdLst>
   <p:sldIdLst>
-    <p:sldId xmlns:r="http://schemas.openxmlformats.org/officeDocument/2006/relationships" id="256" r:id="R487b22fe371d4245"/>
-    <p:sldId xmlns:r="http://schemas.openxmlformats.org/officeDocument/2006/relationships" id="257" r:id="R51442ea95ba64979"/>
-    <p:sldId xmlns:r="http://schemas.openxmlformats.org/officeDocument/2006/relationships" id="258" r:id="R794f063238314652"/>
-    <p:sldId xmlns:r="http://schemas.openxmlformats.org/officeDocument/2006/relationships" id="259" r:id="Rd768817a4f0440db"/>
-    <p:sldId xmlns:r="http://schemas.openxmlformats.org/officeDocument/2006/relationships" id="260" r:id="R9de2102ce46a45af"/>
-    <p:sldId xmlns:r="http://schemas.openxmlformats.org/officeDocument/2006/relationships" id="261" r:id="R647e47247cf945cc"/>
+    <p:sldId xmlns:r="http://schemas.openxmlformats.org/officeDocument/2006/relationships" id="256" r:id="R3fe38561f5414208"/>
+    <p:sldId xmlns:r="http://schemas.openxmlformats.org/officeDocument/2006/relationships" id="257" r:id="Ra4a7522427a54c93"/>
+    <p:sldId xmlns:r="http://schemas.openxmlformats.org/officeDocument/2006/relationships" id="258" r:id="Ra4bf9f4f8e0d4905"/>
+    <p:sldId xmlns:r="http://schemas.openxmlformats.org/officeDocument/2006/relationships" id="259" r:id="Rf1cbb9c973ea4203"/>
+    <p:sldId xmlns:r="http://schemas.openxmlformats.org/officeDocument/2006/relationships" id="260" r:id="R66a8145220134d14"/>
+    <p:sldId xmlns:r="http://schemas.openxmlformats.org/officeDocument/2006/relationships" id="261" r:id="R18b6c206444743ac"/>
   </p:sldIdLst>
   <p:sldSz cx="12192000" cy="6858000"/>
   <p:notesSz cx="6858000" cy="9144000"/>
@@ -910,7 +910,7 @@
   </p:cSld>
   <p:clrMap bg1="lt1" tx1="dk1" bg2="lt2" tx2="dk2" accent1="accent1" accent2="accent2" accent3="accent3" accent4="accent4" accent5="accent5" accent6="accent6" hlink="hlink" folHlink="folHlink"/>
   <p:sldLayoutIdLst>
-    <p:sldLayoutId xmlns:r="http://schemas.openxmlformats.org/officeDocument/2006/relationships" id="2147483649" r:id="R4cb39e5ab6e9488c"/>
+    <p:sldLayoutId xmlns:r="http://schemas.openxmlformats.org/officeDocument/2006/relationships" id="2147483649" r:id="Rc5eb24b1071b4c45"/>
   </p:sldLayoutIdLst>
   <p:txStyles>
     <p:titleStyle>
@@ -1454,7 +1454,7 @@
           <p:cNvPr id="4" name="Title-3-1">
             <a:extLst xmlns:a="http://schemas.openxmlformats.org/drawingml/2006/main">
               <a:ext uri="{FF2B5EF4-FFF2-40B4-BE49-F238E27FC236}">
-                <a16:creationId xmlns:a16="http://schemas.microsoft.com/office/drawing/2014/main" id="{9C1D1469-FE50-45C4-9FDC-227F1C196B89}"/>
+                <a16:creationId xmlns:a16="http://schemas.microsoft.com/office/drawing/2014/main" id="{CEA5E1F7-F2AD-4E9E-A653-569DC556BE5F}"/>
               </a:ext>
             </a:extLst>
           </p:cNvPr>
@@ -1512,7 +1512,7 @@
           <p:cNvPr id="2" name="Subtitle-4-2">
             <a:extLst xmlns:a="http://schemas.openxmlformats.org/drawingml/2006/main">
               <a:ext uri="{FF2B5EF4-FFF2-40B4-BE49-F238E27FC236}">
-                <a16:creationId xmlns:a16="http://schemas.microsoft.com/office/drawing/2014/main" id="{400236C4-9908-4183-B7C0-9B2BCB75F700}"/>
+                <a16:creationId xmlns:a16="http://schemas.microsoft.com/office/drawing/2014/main" id="{D1332F41-1328-4955-A6F7-11709A8781D0}"/>
               </a:ext>
             </a:extLst>
           </p:cNvPr>
@@ -1569,7 +1569,7 @@
           <p:cNvPr id="3" name="Subtitle-4-3">
             <a:extLst xmlns:a="http://schemas.openxmlformats.org/drawingml/2006/main">
               <a:ext uri="{FF2B5EF4-FFF2-40B4-BE49-F238E27FC236}">
-                <a16:creationId xmlns:a16="http://schemas.microsoft.com/office/drawing/2014/main" id="{D939A922-4882-4751-9842-AE662D2EE309}"/>
+                <a16:creationId xmlns:a16="http://schemas.microsoft.com/office/drawing/2014/main" id="{6D9030F1-6550-4305-A8E4-2FB3DDD6F570}"/>
               </a:ext>
             </a:extLst>
           </p:cNvPr>
@@ -1624,7 +1624,7 @@
     </p:spTree>
     <p:extLst>
       <p:ext uri="{BB962C8B-B14F-4D97-AF65-F5344CB8AC3E}">
-        <p14:creationId xmlns:p14="http://schemas.microsoft.com/office/powerpoint/2010/main" val="1944816547"/>
+        <p14:creationId xmlns:p14="http://schemas.microsoft.com/office/powerpoint/2010/main" val="1697289791"/>
       </p:ext>
     </p:extLst>
   </p:cSld>
@@ -1648,7 +1648,7 @@
           <p:cNvPr id="6" name="Google-Shape-532-p58-2">
             <a:extLst xmlns:a="http://schemas.openxmlformats.org/drawingml/2006/main">
               <a:ext uri="{FF2B5EF4-FFF2-40B4-BE49-F238E27FC236}">
-                <a16:creationId xmlns:a16="http://schemas.microsoft.com/office/drawing/2014/main" id="{B6DA1693-33F0-4BD9-A167-9A6EDA76F48A}"/>
+                <a16:creationId xmlns:a16="http://schemas.microsoft.com/office/drawing/2014/main" id="{49C8B2D6-610E-4515-B00C-A11127E7ED25}"/>
               </a:ext>
             </a:extLst>
           </p:cNvPr>
@@ -1693,7 +1693,7 @@
           <p:cNvPr id="2" name="Google-Shape-533-p58-3">
             <a:extLst xmlns:a="http://schemas.openxmlformats.org/drawingml/2006/main">
               <a:ext uri="{FF2B5EF4-FFF2-40B4-BE49-F238E27FC236}">
-                <a16:creationId xmlns:a16="http://schemas.microsoft.com/office/drawing/2014/main" id="{3D3F920E-2E3C-4B0E-AA69-8C085A8C8F87}"/>
+                <a16:creationId xmlns:a16="http://schemas.microsoft.com/office/drawing/2014/main" id="{CB28A853-A39B-47B8-8B1C-E3C960D179D6}"/>
               </a:ext>
             </a:extLst>
           </p:cNvPr>
@@ -1750,7 +1750,7 @@
           <p:cNvPr id="3" name="Google-Shape-534-p58-4">
             <a:extLst xmlns:a="http://schemas.openxmlformats.org/drawingml/2006/main">
               <a:ext uri="{FF2B5EF4-FFF2-40B4-BE49-F238E27FC236}">
-                <a16:creationId xmlns:a16="http://schemas.microsoft.com/office/drawing/2014/main" id="{20DB029B-08D3-4205-8714-89D3D238806E}"/>
+                <a16:creationId xmlns:a16="http://schemas.microsoft.com/office/drawing/2014/main" id="{DF55CCBE-66C7-4534-B0D3-75F25EEDC67F}"/>
               </a:ext>
             </a:extLst>
           </p:cNvPr>
@@ -1834,7 +1834,7 @@
           <p:cNvPr id="4" name="Content-Placeholder-1-5">
             <a:extLst xmlns:a="http://schemas.openxmlformats.org/drawingml/2006/main">
               <a:ext uri="{FF2B5EF4-FFF2-40B4-BE49-F238E27FC236}">
-                <a16:creationId xmlns:a16="http://schemas.microsoft.com/office/drawing/2014/main" id="{BA4F9F33-4CEB-4413-A60D-3C249BEDDC83}"/>
+                <a16:creationId xmlns:a16="http://schemas.microsoft.com/office/drawing/2014/main" id="{0770E3E4-BE01-46EC-AE92-1AF5E3ABEE57}"/>
               </a:ext>
             </a:extLst>
           </p:cNvPr>
@@ -1918,7 +1918,7 @@
           <p:cNvPr id="5" name="Content-Placeholder-2-6">
             <a:extLst xmlns:a="http://schemas.openxmlformats.org/drawingml/2006/main">
               <a:ext uri="{FF2B5EF4-FFF2-40B4-BE49-F238E27FC236}">
-                <a16:creationId xmlns:a16="http://schemas.microsoft.com/office/drawing/2014/main" id="{12741FE9-00A6-40C2-AFBE-649B77C2606A}"/>
+                <a16:creationId xmlns:a16="http://schemas.microsoft.com/office/drawing/2014/main" id="{57E11A08-E766-431B-81F4-2780DE1F54FD}"/>
               </a:ext>
             </a:extLst>
           </p:cNvPr>
@@ -2000,7 +2000,7 @@
     </p:spTree>
     <p:extLst>
       <p:ext uri="{BB962C8B-B14F-4D97-AF65-F5344CB8AC3E}">
-        <p14:creationId xmlns:p14="http://schemas.microsoft.com/office/powerpoint/2010/main" val="752479103"/>
+        <p14:creationId xmlns:p14="http://schemas.microsoft.com/office/powerpoint/2010/main" val="1330495642"/>
       </p:ext>
     </p:extLst>
   </p:cSld>
@@ -2024,7 +2024,7 @@
           <p:cNvPr id="13" name="Slide-Number-Placeholder-3-2">
             <a:extLst xmlns:a="http://schemas.openxmlformats.org/drawingml/2006/main">
               <a:ext uri="{FF2B5EF4-FFF2-40B4-BE49-F238E27FC236}">
-                <a16:creationId xmlns:a16="http://schemas.microsoft.com/office/drawing/2014/main" id="{8E2D1A4E-80CC-4BEE-85FA-58B5382C5199}"/>
+                <a16:creationId xmlns:a16="http://schemas.microsoft.com/office/drawing/2014/main" id="{71CE68F5-CB26-4D07-8EF0-8512A010F843}"/>
               </a:ext>
             </a:extLst>
           </p:cNvPr>
@@ -2067,7 +2067,7 @@
           <p:cNvPr id="2" name="Title-10-3">
             <a:extLst xmlns:a="http://schemas.openxmlformats.org/drawingml/2006/main">
               <a:ext uri="{FF2B5EF4-FFF2-40B4-BE49-F238E27FC236}">
-                <a16:creationId xmlns:a16="http://schemas.microsoft.com/office/drawing/2014/main" id="{D68E4FA7-A5B2-442D-A589-9029E053580F}"/>
+                <a16:creationId xmlns:a16="http://schemas.microsoft.com/office/drawing/2014/main" id="{942B2596-AF5D-4B1E-ACCF-C1DF3C95EBD5}"/>
               </a:ext>
             </a:extLst>
           </p:cNvPr>
@@ -2146,7 +2146,7 @@
           <p:cNvPr id="4" name="Google-Shape-2260-p159-5">
             <a:extLst xmlns:a="http://schemas.openxmlformats.org/drawingml/2006/main">
               <a:ext uri="{FF2B5EF4-FFF2-40B4-BE49-F238E27FC236}">
-                <a16:creationId xmlns:a16="http://schemas.microsoft.com/office/drawing/2014/main" id="{8D23E9D2-5CA9-4532-9396-095B015486C9}"/>
+                <a16:creationId xmlns:a16="http://schemas.microsoft.com/office/drawing/2014/main" id="{93185240-BF7E-4C37-9CF7-CF70966E8F21}"/>
               </a:ext>
             </a:extLst>
           </p:cNvPr>
@@ -2173,7 +2173,7 @@
           <p:cNvPr id="5" name="Google-Shape-2261-p159-6">
             <a:extLst xmlns:a="http://schemas.openxmlformats.org/drawingml/2006/main">
               <a:ext uri="{FF2B5EF4-FFF2-40B4-BE49-F238E27FC236}">
-                <a16:creationId xmlns:a16="http://schemas.microsoft.com/office/drawing/2014/main" id="{24C0885A-83F6-4486-A607-DF7B716E90CB}"/>
+                <a16:creationId xmlns:a16="http://schemas.microsoft.com/office/drawing/2014/main" id="{E377CEC5-9D7A-4616-A074-D0EC348AE0EE}"/>
               </a:ext>
             </a:extLst>
           </p:cNvPr>
@@ -2200,7 +2200,7 @@
           <p:cNvPr id="6" name="Google-Shape-2262-p159-7">
             <a:extLst xmlns:a="http://schemas.openxmlformats.org/drawingml/2006/main">
               <a:ext uri="{FF2B5EF4-FFF2-40B4-BE49-F238E27FC236}">
-                <a16:creationId xmlns:a16="http://schemas.microsoft.com/office/drawing/2014/main" id="{90D5DCFF-D57C-4802-BFF4-B394D60A27E4}"/>
+                <a16:creationId xmlns:a16="http://schemas.microsoft.com/office/drawing/2014/main" id="{6D6EABEC-4B40-469E-8387-4E76D3B9F819}"/>
               </a:ext>
             </a:extLst>
           </p:cNvPr>
@@ -2227,7 +2227,7 @@
           <p:cNvPr id="7" name="Content-Placeholder-15-8">
             <a:extLst xmlns:a="http://schemas.openxmlformats.org/drawingml/2006/main">
               <a:ext uri="{FF2B5EF4-FFF2-40B4-BE49-F238E27FC236}">
-                <a16:creationId xmlns:a16="http://schemas.microsoft.com/office/drawing/2014/main" id="{1A1F0C2F-8B0D-4A3D-A73B-560291C2986B}"/>
+                <a16:creationId xmlns:a16="http://schemas.microsoft.com/office/drawing/2014/main" id="{8419FE5F-C25B-44FA-ADF0-91328A33FE0B}"/>
               </a:ext>
             </a:extLst>
           </p:cNvPr>
@@ -2284,7 +2284,7 @@
           <p:cNvPr id="8" name="Content-Placeholder-15-9">
             <a:extLst xmlns:a="http://schemas.openxmlformats.org/drawingml/2006/main">
               <a:ext uri="{FF2B5EF4-FFF2-40B4-BE49-F238E27FC236}">
-                <a16:creationId xmlns:a16="http://schemas.microsoft.com/office/drawing/2014/main" id="{20978F44-45CE-4BB2-A750-D198A2804F3D}"/>
+                <a16:creationId xmlns:a16="http://schemas.microsoft.com/office/drawing/2014/main" id="{D918E47F-ABAF-4266-8516-D4A12F897C97}"/>
               </a:ext>
             </a:extLst>
           </p:cNvPr>
@@ -2341,7 +2341,7 @@
           <p:cNvPr id="9" name="Content-Placeholder-15-10">
             <a:extLst xmlns:a="http://schemas.openxmlformats.org/drawingml/2006/main">
               <a:ext uri="{FF2B5EF4-FFF2-40B4-BE49-F238E27FC236}">
-                <a16:creationId xmlns:a16="http://schemas.microsoft.com/office/drawing/2014/main" id="{729D3F90-4FAF-4831-8AB7-3A8FADD0F1C4}"/>
+                <a16:creationId xmlns:a16="http://schemas.microsoft.com/office/drawing/2014/main" id="{A8D7CE20-6F50-49C7-9DF0-6EC458107FAC}"/>
               </a:ext>
             </a:extLst>
           </p:cNvPr>
@@ -2398,7 +2398,7 @@
           <p:cNvPr id="10" name="Text-Placeholder-16-11">
             <a:extLst xmlns:a="http://schemas.openxmlformats.org/drawingml/2006/main">
               <a:ext uri="{FF2B5EF4-FFF2-40B4-BE49-F238E27FC236}">
-                <a16:creationId xmlns:a16="http://schemas.microsoft.com/office/drawing/2014/main" id="{51B5A434-17DD-470E-A108-E4B8C4A1FABF}"/>
+                <a16:creationId xmlns:a16="http://schemas.microsoft.com/office/drawing/2014/main" id="{5437CE71-8713-4D8B-AA68-A60F11306136}"/>
               </a:ext>
             </a:extLst>
           </p:cNvPr>
@@ -2482,7 +2482,7 @@
           <p:cNvPr id="11" name="Text-Placeholder-16-12">
             <a:extLst xmlns:a="http://schemas.openxmlformats.org/drawingml/2006/main">
               <a:ext uri="{FF2B5EF4-FFF2-40B4-BE49-F238E27FC236}">
-                <a16:creationId xmlns:a16="http://schemas.microsoft.com/office/drawing/2014/main" id="{7A5181DA-AA7A-41E1-A6FD-F50393195447}"/>
+                <a16:creationId xmlns:a16="http://schemas.microsoft.com/office/drawing/2014/main" id="{4CB594A1-20F8-4051-90FF-A1FD722475EC}"/>
               </a:ext>
             </a:extLst>
           </p:cNvPr>
@@ -2529,7 +2529,7 @@
                 <a:ea typeface="Arial"/>
                 <a:cs typeface="Arial"/>
               </a:rPr>
-              <a:t>8개 Profile 독립 검색</a:t>
+              <a:t>9개 근거 영역 독립 검색</a:t>
             </a:r>
           </a:p>
           <a:p xmlns:a="http://schemas.openxmlformats.org/drawingml/2006/main">
@@ -2556,7 +2556,7 @@
                 <a:ea typeface="Arial"/>
                 <a:cs typeface="Arial"/>
               </a:rPr>
-              <a:t>근거 있음과 없음 모두 Coverage에 남긴다.</a:t>
+              <a:t>8개 제품 Profile과 승인된 플랫폼 참조를 모두 Coverage에 남긴다.</a:t>
             </a:r>
           </a:p>
         </p:txBody>
@@ -2566,7 +2566,7 @@
           <p:cNvPr id="12" name="Text-Placeholder-16-13">
             <a:extLst xmlns:a="http://schemas.openxmlformats.org/drawingml/2006/main">
               <a:ext uri="{FF2B5EF4-FFF2-40B4-BE49-F238E27FC236}">
-                <a16:creationId xmlns:a16="http://schemas.microsoft.com/office/drawing/2014/main" id="{3045095F-9040-4BF7-93ED-AFDFF3FD51DC}"/>
+                <a16:creationId xmlns:a16="http://schemas.microsoft.com/office/drawing/2014/main" id="{C3512AA5-FEF3-418E-B902-B6E3FCC6E6A3}"/>
               </a:ext>
             </a:extLst>
           </p:cNvPr>
@@ -2648,7 +2648,7 @@
     </p:spTree>
     <p:extLst>
       <p:ext uri="{BB962C8B-B14F-4D97-AF65-F5344CB8AC3E}">
-        <p14:creationId xmlns:p14="http://schemas.microsoft.com/office/powerpoint/2010/main" val="572769017"/>
+        <p14:creationId xmlns:p14="http://schemas.microsoft.com/office/powerpoint/2010/main" val="895594301"/>
       </p:ext>
     </p:extLst>
   </p:cSld>
@@ -2672,7 +2672,7 @@
           <p:cNvPr id="6" name="Google-Shape-532-p58-2">
             <a:extLst xmlns:a="http://schemas.openxmlformats.org/drawingml/2006/main">
               <a:ext uri="{FF2B5EF4-FFF2-40B4-BE49-F238E27FC236}">
-                <a16:creationId xmlns:a16="http://schemas.microsoft.com/office/drawing/2014/main" id="{FE39D154-3E41-4309-9532-5C4B21847CC1}"/>
+                <a16:creationId xmlns:a16="http://schemas.microsoft.com/office/drawing/2014/main" id="{15D117D5-DF9C-4A06-B460-39000E63854C}"/>
               </a:ext>
             </a:extLst>
           </p:cNvPr>
@@ -2717,7 +2717,7 @@
           <p:cNvPr id="2" name="Google-Shape-533-p58-3">
             <a:extLst xmlns:a="http://schemas.openxmlformats.org/drawingml/2006/main">
               <a:ext uri="{FF2B5EF4-FFF2-40B4-BE49-F238E27FC236}">
-                <a16:creationId xmlns:a16="http://schemas.microsoft.com/office/drawing/2014/main" id="{974B9B60-CF7F-44BB-806B-6D9764CECFD1}"/>
+                <a16:creationId xmlns:a16="http://schemas.microsoft.com/office/drawing/2014/main" id="{1016FC27-41CB-42A3-B466-7BCD7A510BC5}"/>
               </a:ext>
             </a:extLst>
           </p:cNvPr>
@@ -2774,7 +2774,7 @@
           <p:cNvPr id="3" name="Google-Shape-534-p58-4">
             <a:extLst xmlns:a="http://schemas.openxmlformats.org/drawingml/2006/main">
               <a:ext uri="{FF2B5EF4-FFF2-40B4-BE49-F238E27FC236}">
-                <a16:creationId xmlns:a16="http://schemas.microsoft.com/office/drawing/2014/main" id="{309103CE-F6AE-4AAB-BBA0-273C40564B28}"/>
+                <a16:creationId xmlns:a16="http://schemas.microsoft.com/office/drawing/2014/main" id="{488E6779-76D5-4CD9-BA97-6B7B56C5F5DB}"/>
               </a:ext>
             </a:extLst>
           </p:cNvPr>
@@ -2858,7 +2858,7 @@
           <p:cNvPr id="4" name="Content-Placeholder-1-5">
             <a:extLst xmlns:a="http://schemas.openxmlformats.org/drawingml/2006/main">
               <a:ext uri="{FF2B5EF4-FFF2-40B4-BE49-F238E27FC236}">
-                <a16:creationId xmlns:a16="http://schemas.microsoft.com/office/drawing/2014/main" id="{6AD6F207-E1A8-4AD5-8A32-7B518C35F115}"/>
+                <a16:creationId xmlns:a16="http://schemas.microsoft.com/office/drawing/2014/main" id="{0FF63420-F62E-4C4E-85BF-0BB9634876BF}"/>
               </a:ext>
             </a:extLst>
           </p:cNvPr>
@@ -2942,7 +2942,7 @@
           <p:cNvPr id="5" name="Content-Placeholder-2-6">
             <a:extLst xmlns:a="http://schemas.openxmlformats.org/drawingml/2006/main">
               <a:ext uri="{FF2B5EF4-FFF2-40B4-BE49-F238E27FC236}">
-                <a16:creationId xmlns:a16="http://schemas.microsoft.com/office/drawing/2014/main" id="{1E9446F6-62C6-46BC-B912-1971FA3BC31F}"/>
+                <a16:creationId xmlns:a16="http://schemas.microsoft.com/office/drawing/2014/main" id="{02117D24-7C30-4BBE-A401-FFD9DC072361}"/>
               </a:ext>
             </a:extLst>
           </p:cNvPr>
@@ -3024,7 +3024,7 @@
     </p:spTree>
     <p:extLst>
       <p:ext uri="{BB962C8B-B14F-4D97-AF65-F5344CB8AC3E}">
-        <p14:creationId xmlns:p14="http://schemas.microsoft.com/office/powerpoint/2010/main" val="1546729124"/>
+        <p14:creationId xmlns:p14="http://schemas.microsoft.com/office/powerpoint/2010/main" val="1935619858"/>
       </p:ext>
     </p:extLst>
   </p:cSld>
@@ -3048,7 +3048,7 @@
           <p:cNvPr id="13" name="Rounded-Rectangle-5-1">
             <a:extLst xmlns:a="http://schemas.openxmlformats.org/drawingml/2006/main">
               <a:ext uri="{FF2B5EF4-FFF2-40B4-BE49-F238E27FC236}">
-                <a16:creationId xmlns:a16="http://schemas.microsoft.com/office/drawing/2014/main" id="{B0520D99-A12B-48CC-8BC9-6A3FF6BAC124}"/>
+                <a16:creationId xmlns:a16="http://schemas.microsoft.com/office/drawing/2014/main" id="{F7431F98-07AB-41BF-867E-89E76BEB2AA5}"/>
               </a:ext>
             </a:extLst>
           </p:cNvPr>
@@ -3077,7 +3077,7 @@
           <p:cNvPr id="2" name="Rounded-Rectangle-6-2">
             <a:extLst xmlns:a="http://schemas.openxmlformats.org/drawingml/2006/main">
               <a:ext uri="{FF2B5EF4-FFF2-40B4-BE49-F238E27FC236}">
-                <a16:creationId xmlns:a16="http://schemas.microsoft.com/office/drawing/2014/main" id="{9171CBC2-DD2B-4723-BEB3-FD5A6C73F7DD}"/>
+                <a16:creationId xmlns:a16="http://schemas.microsoft.com/office/drawing/2014/main" id="{C62A7182-8094-44E7-8634-0AB67547B355}"/>
               </a:ext>
             </a:extLst>
           </p:cNvPr>
@@ -3106,7 +3106,7 @@
           <p:cNvPr id="3" name="Rounded-Rectangle-7-3">
             <a:extLst xmlns:a="http://schemas.openxmlformats.org/drawingml/2006/main">
               <a:ext uri="{FF2B5EF4-FFF2-40B4-BE49-F238E27FC236}">
-                <a16:creationId xmlns:a16="http://schemas.microsoft.com/office/drawing/2014/main" id="{DC4D4752-F507-42BB-B0E4-C9726CC63974}"/>
+                <a16:creationId xmlns:a16="http://schemas.microsoft.com/office/drawing/2014/main" id="{BA895FB0-5BF0-4719-8D48-076DE578FA30}"/>
               </a:ext>
             </a:extLst>
           </p:cNvPr>
@@ -3135,7 +3135,7 @@
           <p:cNvPr id="4" name="Slide-Number-Placeholder-1-4">
             <a:extLst xmlns:a="http://schemas.openxmlformats.org/drawingml/2006/main">
               <a:ext uri="{FF2B5EF4-FFF2-40B4-BE49-F238E27FC236}">
-                <a16:creationId xmlns:a16="http://schemas.microsoft.com/office/drawing/2014/main" id="{5F583470-33EB-434B-8510-02E193ED5780}"/>
+                <a16:creationId xmlns:a16="http://schemas.microsoft.com/office/drawing/2014/main" id="{2A27523E-F069-4685-A69C-50947F921EF3}"/>
               </a:ext>
             </a:extLst>
           </p:cNvPr>
@@ -3178,7 +3178,7 @@
           <p:cNvPr id="5" name="Title-2-5">
             <a:extLst xmlns:a="http://schemas.openxmlformats.org/drawingml/2006/main">
               <a:ext uri="{FF2B5EF4-FFF2-40B4-BE49-F238E27FC236}">
-                <a16:creationId xmlns:a16="http://schemas.microsoft.com/office/drawing/2014/main" id="{7A7183AC-9498-40E8-BDFA-3502E1C9E0FE}"/>
+                <a16:creationId xmlns:a16="http://schemas.microsoft.com/office/drawing/2014/main" id="{DF758680-7285-4187-9E4C-B0E89AEFFFFE}"/>
               </a:ext>
             </a:extLst>
           </p:cNvPr>
@@ -3235,7 +3235,7 @@
           <p:cNvPr id="6" name="Content-Placeholder-9-6">
             <a:extLst xmlns:a="http://schemas.openxmlformats.org/drawingml/2006/main">
               <a:ext uri="{FF2B5EF4-FFF2-40B4-BE49-F238E27FC236}">
-                <a16:creationId xmlns:a16="http://schemas.microsoft.com/office/drawing/2014/main" id="{C57AB196-2EC1-47AC-BAF4-51394331CF47}"/>
+                <a16:creationId xmlns:a16="http://schemas.microsoft.com/office/drawing/2014/main" id="{5BB0C2FB-81BF-4A64-89C9-BC05BBEC9D5D}"/>
               </a:ext>
             </a:extLst>
           </p:cNvPr>
@@ -3292,7 +3292,7 @@
           <p:cNvPr id="7" name="Content-Placeholder-10-7">
             <a:extLst xmlns:a="http://schemas.openxmlformats.org/drawingml/2006/main">
               <a:ext uri="{FF2B5EF4-FFF2-40B4-BE49-F238E27FC236}">
-                <a16:creationId xmlns:a16="http://schemas.microsoft.com/office/drawing/2014/main" id="{0A8552DD-3DFA-4F12-914D-6A9E1200570C}"/>
+                <a16:creationId xmlns:a16="http://schemas.microsoft.com/office/drawing/2014/main" id="{66942391-CD34-4E3B-BF6A-50B992BD3A8F}"/>
               </a:ext>
             </a:extLst>
           </p:cNvPr>
@@ -3339,7 +3339,7 @@
                 <a:ea typeface="Arial"/>
                 <a:cs typeface="Arial"/>
               </a:rPr>
-              <a:t>외부 내부계보 노출</a:t>
+              <a:t>Community 감지 후 Chat 알림</a:t>
             </a:r>
           </a:p>
         </p:txBody>
@@ -3349,7 +3349,7 @@
           <p:cNvPr id="8" name="Content-Placeholder-11-8">
             <a:extLst xmlns:a="http://schemas.openxmlformats.org/drawingml/2006/main">
               <a:ext uri="{FF2B5EF4-FFF2-40B4-BE49-F238E27FC236}">
-                <a16:creationId xmlns:a16="http://schemas.microsoft.com/office/drawing/2014/main" id="{B58E47F9-CD74-465B-8622-D4D356FA46DF}"/>
+                <a16:creationId xmlns:a16="http://schemas.microsoft.com/office/drawing/2014/main" id="{3017C9F4-ECA3-4452-B150-C45564101A1C}"/>
               </a:ext>
             </a:extLst>
           </p:cNvPr>
@@ -3396,7 +3396,7 @@
                 <a:ea typeface="Arial"/>
                 <a:cs typeface="Arial"/>
               </a:rPr>
-              <a:t>Source Profile 검토</a:t>
+              <a:t>제품·플랫폼 근거 검토</a:t>
             </a:r>
           </a:p>
         </p:txBody>
@@ -3406,7 +3406,7 @@
           <p:cNvPr id="9" name="Content-Placeholder-9-9">
             <a:extLst xmlns:a="http://schemas.openxmlformats.org/drawingml/2006/main">
               <a:ext uri="{FF2B5EF4-FFF2-40B4-BE49-F238E27FC236}">
-                <a16:creationId xmlns:a16="http://schemas.microsoft.com/office/drawing/2014/main" id="{372919A8-3B3A-43E1-B757-80C44E75344A}"/>
+                <a16:creationId xmlns:a16="http://schemas.microsoft.com/office/drawing/2014/main" id="{D6B5E193-4ABA-4FC1-AA88-5DA7F9182B00}"/>
               </a:ext>
             </a:extLst>
           </p:cNvPr>
@@ -3453,7 +3453,7 @@
                 <a:ea typeface="Arial"/>
                 <a:cs typeface="Arial"/>
               </a:rPr>
-              <a:t>163 PASS</a:t>
+              <a:t>172 PASS</a:t>
             </a:r>
           </a:p>
         </p:txBody>
@@ -3463,7 +3463,7 @@
           <p:cNvPr id="10" name="Content-Placeholder-9-10">
             <a:extLst xmlns:a="http://schemas.openxmlformats.org/drawingml/2006/main">
               <a:ext uri="{FF2B5EF4-FFF2-40B4-BE49-F238E27FC236}">
-                <a16:creationId xmlns:a16="http://schemas.microsoft.com/office/drawing/2014/main" id="{A5A42C46-55FC-422F-A795-D515F39A14D5}"/>
+                <a16:creationId xmlns:a16="http://schemas.microsoft.com/office/drawing/2014/main" id="{9DBA339A-BDFE-4281-97DF-274EC97BED59}"/>
               </a:ext>
             </a:extLst>
           </p:cNvPr>
@@ -3510,7 +3510,7 @@
                 <a:ea typeface="Arial"/>
                 <a:cs typeface="Arial"/>
               </a:rPr>
-              <a:t>8 / 8</a:t>
+              <a:t>9 / 9</a:t>
             </a:r>
           </a:p>
         </p:txBody>
@@ -3520,7 +3520,7 @@
           <p:cNvPr id="11" name="Content-Placeholder-9-11">
             <a:extLst xmlns:a="http://schemas.openxmlformats.org/drawingml/2006/main">
               <a:ext uri="{FF2B5EF4-FFF2-40B4-BE49-F238E27FC236}">
-                <a16:creationId xmlns:a16="http://schemas.microsoft.com/office/drawing/2014/main" id="{E7741480-C59D-4EF1-96E4-2C3829D1BD46}"/>
+                <a16:creationId xmlns:a16="http://schemas.microsoft.com/office/drawing/2014/main" id="{67BBABA2-7869-4B5D-8B02-225B332B337F}"/>
               </a:ext>
             </a:extLst>
           </p:cNvPr>
@@ -3567,7 +3567,7 @@
                 <a:ea typeface="Arial"/>
                 <a:cs typeface="Arial"/>
               </a:rPr>
-              <a:t>0건</a:t>
+              <a:t>10초</a:t>
             </a:r>
           </a:p>
         </p:txBody>
@@ -3577,7 +3577,7 @@
           <p:cNvPr id="12" name="Content-Placeholder-15-12">
             <a:extLst xmlns:a="http://schemas.openxmlformats.org/drawingml/2006/main">
               <a:ext uri="{FF2B5EF4-FFF2-40B4-BE49-F238E27FC236}">
-                <a16:creationId xmlns:a16="http://schemas.microsoft.com/office/drawing/2014/main" id="{AF842FCF-5584-43C7-B650-A69154E99837}"/>
+                <a16:creationId xmlns:a16="http://schemas.microsoft.com/office/drawing/2014/main" id="{A6FD25D0-11B8-4CB6-9EC9-51362C8153E1}"/>
               </a:ext>
             </a:extLst>
           </p:cNvPr>
@@ -3624,7 +3624,7 @@
                 <a:ea typeface="Arial"/>
                 <a:cs typeface="Arial"/>
               </a:rPr>
-              <a:t>Mold 콘솔 연결중 · Discussion #152</a:t>
+              <a:t>Mold 콘솔 답변 · 신규 글 선제 알림</a:t>
             </a:r>
           </a:p>
           <a:p xmlns:a="http://schemas.openxmlformats.org/drawingml/2006/main">
@@ -3651,7 +3651,7 @@
                 <a:ea typeface="Arial"/>
                 <a:cs typeface="Arial"/>
               </a:rPr>
-              <a:t>Ubuntu 24.04 · AI Gateway 0.11.2 · Chat/Community 답변 검증 · GitHub→Chat 무변경</a:t>
+              <a:t>Ubuntu 24.04 · AI Gateway 0.11.3 · Discussion #153/#155 · GitHub→Chat 무변경</a:t>
             </a:r>
           </a:p>
         </p:txBody>
@@ -3659,7 +3659,7 @@
     </p:spTree>
     <p:extLst>
       <p:ext uri="{BB962C8B-B14F-4D97-AF65-F5344CB8AC3E}">
-        <p14:creationId xmlns:p14="http://schemas.microsoft.com/office/powerpoint/2010/main" val="2084644867"/>
+        <p14:creationId xmlns:p14="http://schemas.microsoft.com/office/powerpoint/2010/main" val="2020900731"/>
       </p:ext>
     </p:extLst>
   </p:cSld>
@@ -3683,7 +3683,7 @@
           <p:cNvPr id="4" name="Title-3-1">
             <a:extLst xmlns:a="http://schemas.openxmlformats.org/drawingml/2006/main">
               <a:ext uri="{FF2B5EF4-FFF2-40B4-BE49-F238E27FC236}">
-                <a16:creationId xmlns:a16="http://schemas.microsoft.com/office/drawing/2014/main" id="{EFECAE61-A884-4F30-95CA-3BCB986FC599}"/>
+                <a16:creationId xmlns:a16="http://schemas.microsoft.com/office/drawing/2014/main" id="{D9B1C540-CF89-435F-A2C5-48C87B252991}"/>
               </a:ext>
             </a:extLst>
           </p:cNvPr>
@@ -3741,7 +3741,7 @@
           <p:cNvPr id="2" name="Subtitle-4-2">
             <a:extLst xmlns:a="http://schemas.openxmlformats.org/drawingml/2006/main">
               <a:ext uri="{FF2B5EF4-FFF2-40B4-BE49-F238E27FC236}">
-                <a16:creationId xmlns:a16="http://schemas.microsoft.com/office/drawing/2014/main" id="{5FFF9EDE-68B4-47A3-B3EF-30B425C63A95}"/>
+                <a16:creationId xmlns:a16="http://schemas.microsoft.com/office/drawing/2014/main" id="{26BEA0B4-2FB3-4031-A52E-B3E67D491C5E}"/>
               </a:ext>
             </a:extLst>
           </p:cNvPr>
@@ -3842,7 +3842,7 @@
                 <a:ea typeface="Arial"/>
                 <a:cs typeface="Arial"/>
               </a:rPr>
-              <a:t>다음 단계 · Issue #23 운영 KPI</a:t>
+              <a:t>상세=답변 · 근거=명시 요청 · 신규 글 선제 알림</a:t>
             </a:r>
           </a:p>
         </p:txBody>
@@ -3852,7 +3852,7 @@
           <p:cNvPr id="3" name="Subtitle-4-3">
             <a:extLst xmlns:a="http://schemas.openxmlformats.org/drawingml/2006/main">
               <a:ext uri="{FF2B5EF4-FFF2-40B4-BE49-F238E27FC236}">
-                <a16:creationId xmlns:a16="http://schemas.microsoft.com/office/drawing/2014/main" id="{DCF64F3E-E7DD-40A0-B32F-7B64AA261F0B}"/>
+                <a16:creationId xmlns:a16="http://schemas.microsoft.com/office/drawing/2014/main" id="{7B2D6DC0-0AAE-448F-9168-DF78B18CE8B0}"/>
               </a:ext>
             </a:extLst>
           </p:cNvPr>
@@ -3907,7 +3907,7 @@
     </p:spTree>
     <p:extLst>
       <p:ext uri="{BB962C8B-B14F-4D97-AF65-F5344CB8AC3E}">
-        <p14:creationId xmlns:p14="http://schemas.microsoft.com/office/powerpoint/2010/main" val="1347260895"/>
+        <p14:creationId xmlns:p14="http://schemas.microsoft.com/office/powerpoint/2010/main" val="1223260806"/>
       </p:ext>
     </p:extLst>
   </p:cSld>

</xml_diff>